<commit_message>
Combine the Test and Implement steps into one slide
Co-Authored-By: Claude Sonnet 5.5 <noreply@anthropic.com>
Claude-Session: https://claude.ai/code/session_01G91AnPjqU4wM8Huv9evsac
</commit_message>
<xml_diff>
--- a/docs/plac3r.pptx
+++ b/docs/plac3r.pptx
@@ -11,10 +11,9 @@
     <p:sldId id="259" r:id="rId5"/>
     <p:sldId id="260" r:id="rId6"/>
     <p:sldId id="261" r:id="rId7"/>
-    <p:sldId id="262" r:id="rId8"/>
   </p:sldIdLst>
   <p:notesMasterIdLst>
-    <p:notesMasterId r:id="rId9"/>
+    <p:notesMasterId r:id="rId8"/>
   </p:notesMasterIdLst>
   <p:sldSz cx="9144000" cy="5143500"/>
   <p:notesSz cx="5143500" cy="9144000"/>
@@ -948,7 +947,7 @@
           <a:p>
             <a:r>
               <a:rPr lang="en-US" dirty="0"/>
-              <a:t>Test: every number was measured on one real machine against Ollama's own default placement. The coding task ran through a real third-party agent and was checked independently. We also report where it does not help: web-bound research, and a model too weak for the job.</a:t>
+              <a:t>Test and Implement: every number was measured on one real machine against Ollama's own default placement. The coding task ran through a real third-party agent and was checked independently. We also report where it does not help: web-bound research, and a model too weak for the job. To implement, install the requirements, start the proxy on port 11435 and point your agent at it. Requirements: Python 3.10 or newer, Ollama and a discrete NVIDIA GPU. Built and tested on Windows; Linux is untested. Honest status: the technical build is done and validated, but customer discovery has not happened yet, so the next step is interviews and feedback, which restarts the loop at Empathize.</a:t>
             </a:r>
             <a:endParaRPr lang="en-US" dirty="0"/>
           </a:p>
@@ -972,94 +971,6 @@
             <a:fld id="{F7021451-1387-4CA6-816F-3879F97B5CBC}" type="slidenum">
               <a:rPr lang="en-US"/>
               <a:t>6</a:t>
-            </a:fld>
-            <a:endParaRPr lang="en-US"/>
-          </a:p>
-        </p:txBody>
-      </p:sp>
-    </p:spTree>
-    <p:extLst>
-      <p:ext uri="{BB962C8B-B14F-4D97-AF65-F5344CB8AC3E}">
-        <p14:creationId xmlns:p14="http://schemas.microsoft.com/office/powerpoint/2010/main" val="1024086991"/>
-      </p:ext>
-    </p:extLst>
-  </p:cSld>
-  <p:clrMapOvr>
-    <a:masterClrMapping/>
-  </p:clrMapOvr>
-</p:notes>
-</file>
-
-<file path=ppt/notesSlides/notesSlide7.xml><?xml version="1.0" encoding="utf-8"?>
-<p:notes xmlns:a="http://schemas.openxmlformats.org/drawingml/2006/main" xmlns:r="http://schemas.openxmlformats.org/officeDocument/2006/relationships" xmlns:p="http://schemas.openxmlformats.org/presentationml/2006/main">
-  <p:cSld>
-    <p:spTree>
-      <p:nvGrpSpPr>
-        <p:cNvPr id="1" name=""/>
-        <p:cNvGrpSpPr/>
-        <p:nvPr/>
-      </p:nvGrpSpPr>
-      <p:grpSpPr>
-        <a:xfrm>
-          <a:off x="0" y="0"/>
-          <a:ext cx="0" cy="0"/>
-          <a:chOff x="0" y="0"/>
-          <a:chExt cx="0" cy="0"/>
-        </a:xfrm>
-      </p:grpSpPr>
-      <p:sp>
-        <p:nvSpPr>
-          <p:cNvPr id="2" name="Slide Image Placeholder 1"/>
-          <p:cNvSpPr>
-            <a:spLocks noGrp="1" noRot="1" noChangeAspect="1"/>
-          </p:cNvSpPr>
-          <p:nvPr>
-            <p:ph type="sldImg"/>
-          </p:nvPr>
-        </p:nvSpPr>
-        <p:spPr/>
-      </p:sp>
-      <p:sp>
-        <p:nvSpPr>
-          <p:cNvPr id="3" name="Notes Placeholder 2"/>
-          <p:cNvSpPr>
-            <a:spLocks noGrp="1"/>
-          </p:cNvSpPr>
-          <p:nvPr>
-            <p:ph type="body" idx="1"/>
-          </p:nvPr>
-        </p:nvSpPr>
-        <p:spPr/>
-        <p:txBody>
-          <a:bodyPr/>
-          <a:lstStyle/>
-          <a:p>
-            <a:r>
-              <a:rPr lang="en-US" dirty="0"/>
-              <a:t>Implement: requirements are Python 3.10 or newer, Ollama and a discrete NVIDIA GPU. Built and tested on Windows; Linux is untested. Honest status: the technical build is done and validated, but customer discovery has not happened yet, so the next step is interviews and feedback, which restarts the loop at Empathize.</a:t>
-            </a:r>
-            <a:endParaRPr lang="en-US" dirty="0"/>
-          </a:p>
-        </p:txBody>
-      </p:sp>
-      <p:sp>
-        <p:nvSpPr>
-          <p:cNvPr id="4" name="Slide Number Placeholder 3"/>
-          <p:cNvSpPr>
-            <a:spLocks noGrp="1"/>
-          </p:cNvSpPr>
-          <p:nvPr>
-            <p:ph type="sldNum" sz="quarter" idx="10"/>
-          </p:nvPr>
-        </p:nvSpPr>
-        <p:spPr/>
-        <p:txBody>
-          <a:bodyPr/>
-          <a:lstStyle/>
-          <a:p>
-            <a:fld id="{F7021451-1387-4CA6-816F-3879F97B5CBC}" type="slidenum">
-              <a:rPr lang="en-US"/>
-              <a:t>7</a:t>
             </a:fld>
             <a:endParaRPr lang="en-US"/>
           </a:p>
@@ -1559,7 +1470,7 @@
                 <a:ea typeface="Arial" pitchFamily="34" charset="-122"/>
                 <a:cs typeface="Arial" pitchFamily="34" charset="-120"/>
               </a:rPr>
-              <a:t>EMPATHIZE  ·  DEFINE  ·  IDEATE  ·  PROTOTYPE  ·  TEST  ·  IMPLEMENT</a:t>
+              <a:t>EMPATHIZE  ·  DEFINE  ·  IDEATE  ·  PROTOTYPE  ·  TEST &amp; IMPLEMENT</a:t>
             </a:r>
             <a:endParaRPr lang="en-US" sz="1200" dirty="0"/>
           </a:p>
@@ -1787,7 +1698,7 @@
         <p:spPr>
           <a:xfrm>
             <a:off x="411480" y="3611880"/>
-            <a:ext cx="2286000" cy="1097280"/>
+            <a:ext cx="2286000" cy="1005840"/>
           </a:xfrm>
           <a:prstGeom prst="rect">
             <a:avLst/>
@@ -2532,7 +2443,7 @@
         <p:spPr>
           <a:xfrm>
             <a:off x="411480" y="3611880"/>
-            <a:ext cx="2286000" cy="1097280"/>
+            <a:ext cx="2286000" cy="1005840"/>
           </a:xfrm>
           <a:prstGeom prst="rect">
             <a:avLst/>
@@ -3224,7 +3135,7 @@
         <p:spPr>
           <a:xfrm>
             <a:off x="411480" y="3611880"/>
-            <a:ext cx="2286000" cy="1097280"/>
+            <a:ext cx="2286000" cy="1005840"/>
           </a:xfrm>
           <a:prstGeom prst="rect">
             <a:avLst/>
@@ -4406,7 +4317,7 @@
         <p:spPr>
           <a:xfrm>
             <a:off x="411480" y="3611880"/>
-            <a:ext cx="2286000" cy="1097280"/>
+            <a:ext cx="2286000" cy="1005840"/>
           </a:xfrm>
           <a:prstGeom prst="rect">
             <a:avLst/>
@@ -5404,7 +5315,7 @@
         <p:spPr>
           <a:xfrm>
             <a:off x="411480" y="1645920"/>
-            <a:ext cx="2377440" cy="548640"/>
+            <a:ext cx="2377440" cy="914400"/>
           </a:xfrm>
           <a:prstGeom prst="rect">
             <a:avLst/>
@@ -5420,7 +5331,7 @@
               <a:buNone/>
             </a:pPr>
             <a:r>
-              <a:rPr lang="en-US" sz="3000" b="1" dirty="0">
+              <a:rPr lang="en-US" sz="2600" b="1" dirty="0">
                 <a:solidFill>
                   <a:srgbClr val="FFFFFF"/>
                 </a:solidFill>
@@ -5428,9 +5339,9 @@
                 <a:ea typeface="Arial" pitchFamily="34" charset="-122"/>
                 <a:cs typeface="Arial" pitchFamily="34" charset="-120"/>
               </a:rPr>
-              <a:t>Test</a:t>
-            </a:r>
-            <a:endParaRPr lang="en-US" sz="3000" dirty="0"/>
+              <a:t>Test &amp; Implement</a:t>
+            </a:r>
+            <a:endParaRPr lang="en-US" sz="2600" dirty="0"/>
           </a:p>
         </p:txBody>
       </p:sp>
@@ -5442,7 +5353,7 @@
         </p:nvSpPr>
         <p:spPr>
           <a:xfrm>
-            <a:off x="411480" y="2240280"/>
+            <a:off x="411480" y="2606040"/>
             <a:ext cx="2286000" cy="731520"/>
           </a:xfrm>
           <a:prstGeom prst="rect">
@@ -5467,7 +5378,7 @@
                 <a:ea typeface="Arial" pitchFamily="34" charset="-122"/>
                 <a:cs typeface="Arial" pitchFamily="34" charset="-120"/>
               </a:rPr>
-              <a:t>Does it really work?</a:t>
+              <a:t>Does it work, and how do people start using it?</a:t>
             </a:r>
             <a:endParaRPr lang="en-US" sz="1400" dirty="0"/>
           </a:p>
@@ -5481,7 +5392,7 @@
         </p:nvSpPr>
         <p:spPr>
           <a:xfrm>
-            <a:off x="411480" y="3337560"/>
+            <a:off x="411480" y="3794760"/>
             <a:ext cx="2286000" cy="228600"/>
           </a:xfrm>
           <a:prstGeom prst="rect">
@@ -5520,8 +5431,8 @@
         </p:nvSpPr>
         <p:spPr>
           <a:xfrm>
-            <a:off x="411480" y="3611880"/>
-            <a:ext cx="2286000" cy="1097280"/>
+            <a:off x="411480" y="4069080"/>
+            <a:ext cx="2286000" cy="1005840"/>
           </a:xfrm>
           <a:prstGeom prst="rect">
             <a:avLst/>
@@ -5545,7 +5456,7 @@
                 <a:ea typeface="Arial" pitchFamily="34" charset="-122"/>
                 <a:cs typeface="Arial" pitchFamily="34" charset="-120"/>
               </a:rPr>
-              <a:t>Measure honestly, including the results you don't like.</a:t>
+              <a:t>Measure honestly, then put it in real hands and make it easy to start.</a:t>
             </a:r>
             <a:endParaRPr lang="en-US" sz="1300" dirty="0"/>
           </a:p>
@@ -5623,7 +5534,7 @@
                 <a:ea typeface="Arial" pitchFamily="34" charset="-122"/>
                 <a:cs typeface="Arial" pitchFamily="34" charset="-120"/>
               </a:rPr>
-              <a:t>We compared plac3r with Ollama's default on a real 8 GB RTX 5060 and checked results with git diff and pytest.</a:t>
+              <a:t>We measured plac3r against Ollama's default on a real 8 GB RTX 5060, checked results with git diff and pytest, and made setup two commands.</a:t>
             </a:r>
             <a:endParaRPr lang="en-US" sz="1700" dirty="0"/>
           </a:p>
@@ -5638,7 +5549,7 @@
         <p:spPr>
           <a:xfrm>
             <a:off x="3246120" y="1691640"/>
-            <a:ext cx="1691640" cy="1508760"/>
+            <a:ext cx="1691640" cy="1188720"/>
           </a:xfrm>
           <a:prstGeom prst="rect">
             <a:avLst/>
@@ -5662,8 +5573,8 @@
         </p:nvSpPr>
         <p:spPr>
           <a:xfrm>
-            <a:off x="3383280" y="1783080"/>
-            <a:ext cx="1463040" cy="685800"/>
+            <a:off x="3383280" y="1755648"/>
+            <a:ext cx="1463040" cy="548640"/>
           </a:xfrm>
           <a:prstGeom prst="rect">
             <a:avLst/>
@@ -5679,7 +5590,7 @@
               <a:buNone/>
             </a:pPr>
             <a:r>
-              <a:rPr lang="en-US" sz="3200" b="1" dirty="0">
+              <a:rPr lang="en-US" sz="2800" b="1" dirty="0">
                 <a:solidFill>
                   <a:srgbClr val="000000"/>
                 </a:solidFill>
@@ -5689,7 +5600,7 @@
               </a:rPr>
               <a:t>+61%</a:t>
             </a:r>
-            <a:endParaRPr lang="en-US" sz="3200" dirty="0"/>
+            <a:endParaRPr lang="en-US" sz="2800" dirty="0"/>
           </a:p>
         </p:txBody>
       </p:sp>
@@ -5701,8 +5612,8 @@
         </p:nvSpPr>
         <p:spPr>
           <a:xfrm>
-            <a:off x="3383280" y="2514600"/>
-            <a:ext cx="1463040" cy="594360"/>
+            <a:off x="3383280" y="2331720"/>
+            <a:ext cx="1463040" cy="502920"/>
           </a:xfrm>
           <a:prstGeom prst="rect">
             <a:avLst/>
@@ -5718,7 +5629,7 @@
               <a:buNone/>
             </a:pPr>
             <a:r>
-              <a:rPr lang="en-US" sz="1200" dirty="0">
+              <a:rPr lang="en-US" sz="1100" dirty="0">
                 <a:solidFill>
                   <a:srgbClr val="595959"/>
                 </a:solidFill>
@@ -5728,7 +5639,7 @@
               </a:rPr>
               <a:t>Qwen2.5-14B decoding speed</a:t>
             </a:r>
-            <a:endParaRPr lang="en-US" sz="1200" dirty="0"/>
+            <a:endParaRPr lang="en-US" sz="1100" dirty="0"/>
           </a:p>
         </p:txBody>
       </p:sp>
@@ -5741,7 +5652,7 @@
         <p:spPr>
           <a:xfrm>
             <a:off x="5120640" y="1691640"/>
-            <a:ext cx="1691640" cy="1508760"/>
+            <a:ext cx="1691640" cy="1188720"/>
           </a:xfrm>
           <a:prstGeom prst="rect">
             <a:avLst/>
@@ -5765,8 +5676,8 @@
         </p:nvSpPr>
         <p:spPr>
           <a:xfrm>
-            <a:off x="5257800" y="1783080"/>
-            <a:ext cx="1463040" cy="685800"/>
+            <a:off x="5257800" y="1755648"/>
+            <a:ext cx="1463040" cy="548640"/>
           </a:xfrm>
           <a:prstGeom prst="rect">
             <a:avLst/>
@@ -5782,7 +5693,7 @@
               <a:buNone/>
             </a:pPr>
             <a:r>
-              <a:rPr lang="en-US" sz="3200" b="1" dirty="0">
+              <a:rPr lang="en-US" sz="2800" b="1" dirty="0">
                 <a:solidFill>
                   <a:srgbClr val="FFFFFF"/>
                 </a:solidFill>
@@ -5792,7 +5703,7 @@
               </a:rPr>
               <a:t>+402%</a:t>
             </a:r>
-            <a:endParaRPr lang="en-US" sz="3200" dirty="0"/>
+            <a:endParaRPr lang="en-US" sz="2800" dirty="0"/>
           </a:p>
         </p:txBody>
       </p:sp>
@@ -5804,8 +5715,8 @@
         </p:nvSpPr>
         <p:spPr>
           <a:xfrm>
-            <a:off x="5257800" y="2514600"/>
-            <a:ext cx="1463040" cy="594360"/>
+            <a:off x="5257800" y="2331720"/>
+            <a:ext cx="1463040" cy="502920"/>
           </a:xfrm>
           <a:prstGeom prst="rect">
             <a:avLst/>
@@ -5821,7 +5732,7 @@
               <a:buNone/>
             </a:pPr>
             <a:r>
-              <a:rPr lang="en-US" sz="1200" dirty="0">
+              <a:rPr lang="en-US" sz="1100" dirty="0">
                 <a:solidFill>
                   <a:srgbClr val="BFBFBF"/>
                 </a:solidFill>
@@ -5831,7 +5742,7 @@
               </a:rPr>
               <a:t>Qwen3.8-27B decoding speed</a:t>
             </a:r>
-            <a:endParaRPr lang="en-US" sz="1200" dirty="0"/>
+            <a:endParaRPr lang="en-US" sz="1100" dirty="0"/>
           </a:p>
         </p:txBody>
       </p:sp>
@@ -5844,7 +5755,7 @@
         <p:spPr>
           <a:xfrm>
             <a:off x="6995160" y="1691640"/>
-            <a:ext cx="1691640" cy="1508760"/>
+            <a:ext cx="1691640" cy="1188720"/>
           </a:xfrm>
           <a:prstGeom prst="rect">
             <a:avLst/>
@@ -5868,8 +5779,8 @@
         </p:nvSpPr>
         <p:spPr>
           <a:xfrm>
-            <a:off x="7132320" y="1783080"/>
-            <a:ext cx="1463040" cy="685800"/>
+            <a:off x="7132320" y="1755648"/>
+            <a:ext cx="1463040" cy="548640"/>
           </a:xfrm>
           <a:prstGeom prst="rect">
             <a:avLst/>
@@ -5885,7 +5796,7 @@
               <a:buNone/>
             </a:pPr>
             <a:r>
-              <a:rPr lang="en-US" sz="3200" b="1" dirty="0">
+              <a:rPr lang="en-US" sz="2800" b="1" dirty="0">
                 <a:solidFill>
                   <a:srgbClr val="000000"/>
                 </a:solidFill>
@@ -5895,7 +5806,7 @@
               </a:rPr>
               <a:t>44%</a:t>
             </a:r>
-            <a:endParaRPr lang="en-US" sz="3200" dirty="0"/>
+            <a:endParaRPr lang="en-US" sz="2800" dirty="0"/>
           </a:p>
         </p:txBody>
       </p:sp>
@@ -5907,8 +5818,8 @@
         </p:nvSpPr>
         <p:spPr>
           <a:xfrm>
-            <a:off x="7132320" y="2514600"/>
-            <a:ext cx="1463040" cy="594360"/>
+            <a:off x="7132320" y="2331720"/>
+            <a:ext cx="1463040" cy="502920"/>
           </a:xfrm>
           <a:prstGeom prst="rect">
             <a:avLst/>
@@ -5924,7 +5835,7 @@
               <a:buNone/>
             </a:pPr>
             <a:r>
-              <a:rPr lang="en-US" sz="1200" dirty="0">
+              <a:rPr lang="en-US" sz="1100" dirty="0">
                 <a:solidFill>
                   <a:srgbClr val="595959"/>
                 </a:solidFill>
@@ -5934,7 +5845,7 @@
               </a:rPr>
               <a:t>less waiting with 4 agents sharing a GPU</a:t>
             </a:r>
-            <a:endParaRPr lang="en-US" sz="1200" dirty="0"/>
+            <a:endParaRPr lang="en-US" sz="1100" dirty="0"/>
           </a:p>
         </p:txBody>
       </p:sp>
@@ -5946,8 +5857,8 @@
         </p:nvSpPr>
         <p:spPr>
           <a:xfrm>
-            <a:off x="3246120" y="3383280"/>
-            <a:ext cx="5440680" cy="1143000"/>
+            <a:off x="3246120" y="3017520"/>
+            <a:ext cx="5440680" cy="685800"/>
           </a:xfrm>
           <a:prstGeom prst="rect">
             <a:avLst/>
@@ -5971,8 +5882,8 @@
         </p:nvSpPr>
         <p:spPr>
           <a:xfrm>
-            <a:off x="3429000" y="3383280"/>
-            <a:ext cx="5074920" cy="1143000"/>
+            <a:off x="3429000" y="3017520"/>
+            <a:ext cx="5074920" cy="685800"/>
           </a:xfrm>
           <a:prstGeom prst="rect">
             <a:avLst/>
@@ -5988,7 +5899,7 @@
               <a:buNone/>
             </a:pPr>
             <a:r>
-              <a:rPr lang="en-US" sz="1300" b="1" dirty="0">
+              <a:rPr lang="en-US" sz="1200" b="1" dirty="0">
                 <a:solidFill>
                   <a:srgbClr val="000000"/>
                 </a:solidFill>
@@ -6002,7 +5913,7 @@
               <a:buNone/>
             </a:pPr>
             <a:r>
-              <a:rPr lang="en-US" sz="1300" dirty="0">
+              <a:rPr lang="en-US" sz="1200" dirty="0">
                 <a:solidFill>
                   <a:srgbClr val="000000"/>
                 </a:solidFill>
@@ -6016,7 +5927,7 @@
               <a:buNone/>
             </a:pPr>
             <a:r>
-              <a:rPr lang="en-US" sz="1300" b="1" dirty="0">
+              <a:rPr lang="en-US" sz="1200" b="1" dirty="0">
                 <a:solidFill>
                   <a:srgbClr val="000000"/>
                 </a:solidFill>
@@ -6030,7 +5941,7 @@
               <a:buNone/>
             </a:pPr>
             <a:r>
-              <a:rPr lang="en-US" sz="1300" dirty="0">
+              <a:rPr lang="en-US" sz="1200" dirty="0">
                 <a:solidFill>
                   <a:srgbClr val="000000"/>
                 </a:solidFill>
@@ -6038,54 +5949,22 @@
                 <a:ea typeface="Arial" pitchFamily="34" charset="-122"/>
                 <a:cs typeface="Arial" pitchFamily="34" charset="-120"/>
               </a:rPr>
-              <a:t>on web-bound research (19.8 s vs 19.9 s), and a model that is too weak still fails.</a:t>
-            </a:r>
-            <a:endParaRPr lang="en-US" sz="1300" dirty="0"/>
-          </a:p>
-        </p:txBody>
-      </p:sp>
-    </p:spTree>
-  </p:cSld>
-  <p:clrMapOvr>
-    <a:masterClrMapping/>
-  </p:clrMapOvr>
-</p:sld>
-</file>
-
-<file path=ppt/slides/slide7.xml><?xml version="1.0" encoding="utf-8"?>
-<p:sld xmlns:a="http://schemas.openxmlformats.org/drawingml/2006/main" xmlns:r="http://schemas.openxmlformats.org/officeDocument/2006/relationships" xmlns:p="http://schemas.openxmlformats.org/presentationml/2006/main">
-  <p:cSld name="Slide 7">
-    <p:bg>
-      <p:bgPr>
-        <a:solidFill>
-          <a:srgbClr val="FFFFFF"/>
-        </a:solidFill>
-      </p:bgPr>
-    </p:bg>
-    <p:spTree>
-      <p:nvGrpSpPr>
-        <p:cNvPr id="1" name=""/>
-        <p:cNvGrpSpPr/>
-        <p:nvPr/>
-      </p:nvGrpSpPr>
-      <p:grpSpPr>
-        <a:xfrm>
-          <a:off x="0" y="0"/>
-          <a:ext cx="0" cy="0"/>
-          <a:chOff x="0" y="0"/>
-          <a:chExt cx="0" cy="0"/>
-        </a:xfrm>
-      </p:grpSpPr>
-      <p:sp>
-        <p:nvSpPr>
-          <p:cNvPr id="2" name="Shape 0"/>
+              <a:t>on web-bound research, and a model that is too weak still fails.</a:t>
+            </a:r>
+            <a:endParaRPr lang="en-US" sz="1200" dirty="0"/>
+          </a:p>
+        </p:txBody>
+      </p:sp>
+      <p:sp>
+        <p:nvSpPr>
+          <p:cNvPr id="22" name="Shape 19"/>
           <p:cNvSpPr/>
           <p:nvPr/>
         </p:nvSpPr>
         <p:spPr>
           <a:xfrm>
-            <a:off x="0" y="0"/>
-            <a:ext cx="2926080" cy="5143500"/>
+            <a:off x="3246120" y="3840480"/>
+            <a:ext cx="5440680" cy="731520"/>
           </a:xfrm>
           <a:prstGeom prst="rect">
             <a:avLst/>
@@ -6103,30 +5982,30 @@
       </p:sp>
       <p:sp>
         <p:nvSpPr>
-          <p:cNvPr id="3" name="Text 1"/>
-          <p:cNvSpPr txBox="1"/>
-          <p:nvPr/>
-        </p:nvSpPr>
-        <p:spPr>
-          <a:xfrm>
-            <a:off x="411480" y="365760"/>
-            <a:ext cx="2286000" cy="1188720"/>
-          </a:xfrm>
-          <a:prstGeom prst="rect">
-            <a:avLst/>
-          </a:prstGeom>
-          <a:noFill/>
-          <a:ln/>
-        </p:spPr>
-        <p:txBody>
-          <a:bodyPr wrap="square" lIns="0" tIns="0" rIns="0" bIns="0" rtlCol="0" anchor="b"/>
-          <a:lstStyle/>
-          <a:p>
-            <a:pPr indent="0" marL="0">
-              <a:buNone/>
-            </a:pPr>
-            <a:r>
-              <a:rPr lang="en-US" sz="8000" b="1" dirty="0">
+          <p:cNvPr id="23" name="Text 20"/>
+          <p:cNvSpPr txBox="1"/>
+          <p:nvPr/>
+        </p:nvSpPr>
+        <p:spPr>
+          <a:xfrm>
+            <a:off x="3429000" y="3840480"/>
+            <a:ext cx="5074920" cy="731520"/>
+          </a:xfrm>
+          <a:prstGeom prst="rect">
+            <a:avLst/>
+          </a:prstGeom>
+          <a:noFill/>
+          <a:ln/>
+        </p:spPr>
+        <p:txBody>
+          <a:bodyPr wrap="square" lIns="0" tIns="0" rIns="0" bIns="0" rtlCol="0" anchor="ctr"/>
+          <a:lstStyle/>
+          <a:p>
+            <a:pPr indent="0" marL="0">
+              <a:buNone/>
+            </a:pPr>
+            <a:r>
+              <a:rPr lang="en-US" sz="1200" b="1" dirty="0">
                 <a:solidFill>
                   <a:srgbClr val="FFFFFF"/>
                 </a:solidFill>
@@ -6134,38 +6013,13 @@
                 <a:ea typeface="Arial" pitchFamily="34" charset="-122"/>
                 <a:cs typeface="Arial" pitchFamily="34" charset="-120"/>
               </a:rPr>
-              <a:t>06</a:t>
-            </a:r>
-            <a:endParaRPr lang="en-US" sz="8000" dirty="0"/>
-          </a:p>
-        </p:txBody>
-      </p:sp>
-      <p:sp>
-        <p:nvSpPr>
-          <p:cNvPr id="4" name="Text 2"/>
-          <p:cNvSpPr txBox="1"/>
-          <p:nvPr/>
-        </p:nvSpPr>
-        <p:spPr>
-          <a:xfrm>
-            <a:off x="411480" y="1645920"/>
-            <a:ext cx="2377440" cy="548640"/>
-          </a:xfrm>
-          <a:prstGeom prst="rect">
-            <a:avLst/>
-          </a:prstGeom>
-          <a:noFill/>
-          <a:ln/>
-        </p:spPr>
-        <p:txBody>
-          <a:bodyPr wrap="square" lIns="0" tIns="0" rIns="0" bIns="0" rtlCol="0" anchor="ctr"/>
-          <a:lstStyle/>
-          <a:p>
-            <a:pPr indent="0" marL="0">
-              <a:buNone/>
-            </a:pPr>
-            <a:r>
-              <a:rPr lang="en-US" sz="3000" b="1" dirty="0">
+              <a:t>Implement: </a:t>
+            </a:r>
+            <a:pPr indent="0" marL="0">
+              <a:buNone/>
+            </a:pPr>
+            <a:r>
+              <a:rPr lang="en-US" sz="1200" dirty="0">
                 <a:solidFill>
                   <a:srgbClr val="FFFFFF"/>
                 </a:solidFill>
@@ -6173,116 +6027,13 @@
                 <a:ea typeface="Arial" pitchFamily="34" charset="-122"/>
                 <a:cs typeface="Arial" pitchFamily="34" charset="-120"/>
               </a:rPr>
-              <a:t>Implement</a:t>
-            </a:r>
-            <a:endParaRPr lang="en-US" sz="3000" dirty="0"/>
-          </a:p>
-        </p:txBody>
-      </p:sp>
-      <p:sp>
-        <p:nvSpPr>
-          <p:cNvPr id="5" name="Text 3"/>
-          <p:cNvSpPr txBox="1"/>
-          <p:nvPr/>
-        </p:nvSpPr>
-        <p:spPr>
-          <a:xfrm>
-            <a:off x="411480" y="2240280"/>
-            <a:ext cx="2286000" cy="731520"/>
-          </a:xfrm>
-          <a:prstGeom prst="rect">
-            <a:avLst/>
-          </a:prstGeom>
-          <a:noFill/>
-          <a:ln/>
-        </p:spPr>
-        <p:txBody>
-          <a:bodyPr wrap="square" lIns="0" tIns="0" rIns="0" bIns="0" rtlCol="0" anchor="t"/>
-          <a:lstStyle/>
-          <a:p>
-            <a:pPr indent="0" marL="0">
-              <a:buNone/>
-            </a:pPr>
-            <a:r>
-              <a:rPr lang="en-US" sz="1400" i="1" dirty="0">
-                <a:solidFill>
-                  <a:srgbClr val="BFBFBF"/>
-                </a:solidFill>
-                <a:latin typeface="Arial" pitchFamily="34" charset="0"/>
-                <a:ea typeface="Arial" pitchFamily="34" charset="-122"/>
-                <a:cs typeface="Arial" pitchFamily="34" charset="-120"/>
-              </a:rPr>
-              <a:t>How do people start using it?</a:t>
-            </a:r>
-            <a:endParaRPr lang="en-US" sz="1400" dirty="0"/>
-          </a:p>
-        </p:txBody>
-      </p:sp>
-      <p:sp>
-        <p:nvSpPr>
-          <p:cNvPr id="6" name="Text 4"/>
-          <p:cNvSpPr txBox="1"/>
-          <p:nvPr/>
-        </p:nvSpPr>
-        <p:spPr>
-          <a:xfrm>
-            <a:off x="411480" y="3337560"/>
-            <a:ext cx="2286000" cy="228600"/>
-          </a:xfrm>
-          <a:prstGeom prst="rect">
-            <a:avLst/>
-          </a:prstGeom>
-          <a:noFill/>
-          <a:ln/>
-        </p:spPr>
-        <p:txBody>
-          <a:bodyPr wrap="square" lIns="0" tIns="0" rIns="0" bIns="0" rtlCol="0" anchor="ctr"/>
-          <a:lstStyle/>
-          <a:p>
-            <a:pPr indent="0" marL="0">
-              <a:buNone/>
-            </a:pPr>
-            <a:r>
-              <a:rPr lang="en-US" sz="1100" b="1" spc="200" kern="0" dirty="0">
-                <a:solidFill>
-                  <a:srgbClr val="8C8C8C"/>
-                </a:solidFill>
-                <a:latin typeface="Arial" pitchFamily="34" charset="0"/>
-                <a:ea typeface="Arial" pitchFamily="34" charset="-122"/>
-                <a:cs typeface="Arial" pitchFamily="34" charset="-120"/>
-              </a:rPr>
-              <a:t>WHAT IT MEANS</a:t>
-            </a:r>
-            <a:endParaRPr lang="en-US" sz="1100" dirty="0"/>
-          </a:p>
-        </p:txBody>
-      </p:sp>
-      <p:sp>
-        <p:nvSpPr>
-          <p:cNvPr id="7" name="Text 5"/>
-          <p:cNvSpPr txBox="1"/>
-          <p:nvPr/>
-        </p:nvSpPr>
-        <p:spPr>
-          <a:xfrm>
-            <a:off x="411480" y="3611880"/>
-            <a:ext cx="2286000" cy="1097280"/>
-          </a:xfrm>
-          <a:prstGeom prst="rect">
-            <a:avLst/>
-          </a:prstGeom>
-          <a:noFill/>
-          <a:ln/>
-        </p:spPr>
-        <p:txBody>
-          <a:bodyPr wrap="square" lIns="0" tIns="0" rIns="0" bIns="0" rtlCol="0" anchor="t"/>
-          <a:lstStyle/>
-          <a:p>
-            <a:pPr indent="0" marL="0">
-              <a:buNone/>
-            </a:pPr>
-            <a:r>
-              <a:rPr lang="en-US" sz="1300" dirty="0">
+              <a:t>pip install -r app/requirements.txt, then python -m app.cli serve --port 11435, then point your agent at that port. </a:t>
+            </a:r>
+            <a:pPr indent="0" marL="0">
+              <a:buNone/>
+            </a:pPr>
+            <a:r>
+              <a:rPr lang="en-US" sz="1200" b="1" dirty="0">
                 <a:solidFill>
                   <a:srgbClr val="FFFFFF"/>
                 </a:solidFill>
@@ -6290,591 +6041,9 @@
                 <a:ea typeface="Arial" pitchFamily="34" charset="-122"/>
                 <a:cs typeface="Arial" pitchFamily="34" charset="-120"/>
               </a:rPr>
-              <a:t>Put the solution in real hands and make it easy to start.</a:t>
-            </a:r>
-            <a:endParaRPr lang="en-US" sz="1300" dirty="0"/>
-          </a:p>
-        </p:txBody>
-      </p:sp>
-      <p:sp>
-        <p:nvSpPr>
-          <p:cNvPr id="8" name="Text 6"/>
-          <p:cNvSpPr txBox="1"/>
-          <p:nvPr/>
-        </p:nvSpPr>
-        <p:spPr>
-          <a:xfrm>
-            <a:off x="3246120" y="411480"/>
-            <a:ext cx="5440680" cy="228600"/>
-          </a:xfrm>
-          <a:prstGeom prst="rect">
-            <a:avLst/>
-          </a:prstGeom>
-          <a:noFill/>
-          <a:ln/>
-        </p:spPr>
-        <p:txBody>
-          <a:bodyPr wrap="square" lIns="0" tIns="0" rIns="0" bIns="0" rtlCol="0" anchor="ctr"/>
-          <a:lstStyle/>
-          <a:p>
-            <a:pPr indent="0" marL="0">
-              <a:buNone/>
-            </a:pPr>
-            <a:r>
-              <a:rPr lang="en-US" sz="1100" b="1" spc="200" kern="0" dirty="0">
-                <a:solidFill>
-                  <a:srgbClr val="8C8C8C"/>
-                </a:solidFill>
-                <a:latin typeface="Arial" pitchFamily="34" charset="0"/>
-                <a:ea typeface="Arial" pitchFamily="34" charset="-122"/>
-                <a:cs typeface="Arial" pitchFamily="34" charset="-120"/>
-              </a:rPr>
-              <a:t>WHAT WE DID</a:t>
-            </a:r>
-            <a:endParaRPr lang="en-US" sz="1100" dirty="0"/>
-          </a:p>
-        </p:txBody>
-      </p:sp>
-      <p:sp>
-        <p:nvSpPr>
-          <p:cNvPr id="9" name="Text 7"/>
-          <p:cNvSpPr txBox="1"/>
-          <p:nvPr/>
-        </p:nvSpPr>
-        <p:spPr>
-          <a:xfrm>
-            <a:off x="3246120" y="685800"/>
-            <a:ext cx="5440680" cy="822960"/>
-          </a:xfrm>
-          <a:prstGeom prst="rect">
-            <a:avLst/>
-          </a:prstGeom>
-          <a:noFill/>
-          <a:ln/>
-        </p:spPr>
-        <p:txBody>
-          <a:bodyPr wrap="square" lIns="0" tIns="0" rIns="0" bIns="0" rtlCol="0" anchor="t"/>
-          <a:lstStyle/>
-          <a:p>
-            <a:pPr indent="0" marL="0">
-              <a:buNone/>
-            </a:pPr>
-            <a:r>
-              <a:rPr lang="en-US" sz="1700" b="1" dirty="0">
-                <a:solidFill>
-                  <a:srgbClr val="000000"/>
-                </a:solidFill>
-                <a:latin typeface="Arial" pitchFamily="34" charset="0"/>
-                <a:ea typeface="Arial" pitchFamily="34" charset="-122"/>
-                <a:cs typeface="Arial" pitchFamily="34" charset="-120"/>
-              </a:rPr>
-              <a:t>Setup is two commands, and existing agent tools don't change.</a:t>
-            </a:r>
-            <a:endParaRPr lang="en-US" sz="1700" dirty="0"/>
-          </a:p>
-        </p:txBody>
-      </p:sp>
-      <p:sp>
-        <p:nvSpPr>
-          <p:cNvPr id="11" name="Shape 8"/>
-          <p:cNvSpPr/>
-          <p:nvPr/>
-        </p:nvSpPr>
-        <p:spPr>
-          <a:xfrm>
-            <a:off x="3246120" y="1691640"/>
-            <a:ext cx="1691640" cy="1508760"/>
-          </a:xfrm>
-          <a:prstGeom prst="rect">
-            <a:avLst/>
-          </a:prstGeom>
-          <a:solidFill>
-            <a:srgbClr val="FFFFFF"/>
-          </a:solidFill>
-          <a:ln w="19050">
-            <a:solidFill>
-              <a:srgbClr val="000000"/>
-            </a:solidFill>
-            <a:prstDash val="solid"/>
-          </a:ln>
-        </p:spPr>
-      </p:sp>
-      <p:sp>
-        <p:nvSpPr>
-          <p:cNvPr id="12" name="Text 9"/>
-          <p:cNvSpPr txBox="1"/>
-          <p:nvPr/>
-        </p:nvSpPr>
-        <p:spPr>
-          <a:xfrm>
-            <a:off x="3383280" y="1783080"/>
-            <a:ext cx="548640" cy="457200"/>
-          </a:xfrm>
-          <a:prstGeom prst="rect">
-            <a:avLst/>
-          </a:prstGeom>
-          <a:noFill/>
-          <a:ln/>
-        </p:spPr>
-        <p:txBody>
-          <a:bodyPr wrap="square" lIns="0" tIns="0" rIns="0" bIns="0" rtlCol="0" anchor="ctr"/>
-          <a:lstStyle/>
-          <a:p>
-            <a:pPr indent="0" marL="0">
-              <a:buNone/>
-            </a:pPr>
-            <a:r>
-              <a:rPr lang="en-US" sz="2800" b="1" dirty="0">
-                <a:solidFill>
-                  <a:srgbClr val="000000"/>
-                </a:solidFill>
-                <a:latin typeface="Arial" pitchFamily="34" charset="0"/>
-                <a:ea typeface="Arial" pitchFamily="34" charset="-122"/>
-                <a:cs typeface="Arial" pitchFamily="34" charset="-120"/>
-              </a:rPr>
-              <a:t>1</a:t>
-            </a:r>
-            <a:endParaRPr lang="en-US" sz="2800" dirty="0"/>
-          </a:p>
-        </p:txBody>
-      </p:sp>
-      <p:sp>
-        <p:nvSpPr>
-          <p:cNvPr id="13" name="Text 10"/>
-          <p:cNvSpPr txBox="1"/>
-          <p:nvPr/>
-        </p:nvSpPr>
-        <p:spPr>
-          <a:xfrm>
-            <a:off x="3840480" y="1783080"/>
-            <a:ext cx="1005840" cy="457200"/>
-          </a:xfrm>
-          <a:prstGeom prst="rect">
-            <a:avLst/>
-          </a:prstGeom>
-          <a:noFill/>
-          <a:ln/>
-        </p:spPr>
-        <p:txBody>
-          <a:bodyPr wrap="square" lIns="0" tIns="0" rIns="0" bIns="0" rtlCol="0" anchor="ctr"/>
-          <a:lstStyle/>
-          <a:p>
-            <a:pPr indent="0" marL="0">
-              <a:buNone/>
-            </a:pPr>
-            <a:r>
-              <a:rPr lang="en-US" sz="1400" b="1" dirty="0">
-                <a:solidFill>
-                  <a:srgbClr val="000000"/>
-                </a:solidFill>
-                <a:latin typeface="Arial" pitchFamily="34" charset="0"/>
-                <a:ea typeface="Arial" pitchFamily="34" charset="-122"/>
-                <a:cs typeface="Arial" pitchFamily="34" charset="-120"/>
-              </a:rPr>
-              <a:t>Install</a:t>
-            </a:r>
-            <a:endParaRPr lang="en-US" sz="1400" dirty="0"/>
-          </a:p>
-        </p:txBody>
-      </p:sp>
-      <p:sp>
-        <p:nvSpPr>
-          <p:cNvPr id="14" name="Text 11"/>
-          <p:cNvSpPr txBox="1"/>
-          <p:nvPr/>
-        </p:nvSpPr>
-        <p:spPr>
-          <a:xfrm>
-            <a:off x="3383280" y="2331720"/>
-            <a:ext cx="1463040" cy="777240"/>
-          </a:xfrm>
-          <a:prstGeom prst="rect">
-            <a:avLst/>
-          </a:prstGeom>
-          <a:noFill/>
-          <a:ln/>
-        </p:spPr>
-        <p:txBody>
-          <a:bodyPr wrap="square" lIns="0" tIns="0" rIns="0" bIns="0" rtlCol="0" anchor="t"/>
-          <a:lstStyle/>
-          <a:p>
-            <a:pPr indent="0" marL="0">
-              <a:buNone/>
-            </a:pPr>
-            <a:r>
-              <a:rPr lang="en-US" sz="1100" dirty="0">
-                <a:solidFill>
-                  <a:srgbClr val="262626"/>
-                </a:solidFill>
-                <a:latin typeface="Courier New" pitchFamily="34" charset="0"/>
-                <a:ea typeface="Courier New" pitchFamily="34" charset="-122"/>
-                <a:cs typeface="Courier New" pitchFamily="34" charset="-120"/>
-              </a:rPr>
-              <a:t>pip install -r app/requirements.txt</a:t>
-            </a:r>
-            <a:endParaRPr lang="en-US" sz="1100" dirty="0"/>
-          </a:p>
-        </p:txBody>
-      </p:sp>
-      <p:sp>
-        <p:nvSpPr>
-          <p:cNvPr id="15" name="Shape 12"/>
-          <p:cNvSpPr/>
-          <p:nvPr/>
-        </p:nvSpPr>
-        <p:spPr>
-          <a:xfrm>
-            <a:off x="5120640" y="1691640"/>
-            <a:ext cx="1691640" cy="1508760"/>
-          </a:xfrm>
-          <a:prstGeom prst="rect">
-            <a:avLst/>
-          </a:prstGeom>
-          <a:solidFill>
-            <a:srgbClr val="000000"/>
-          </a:solidFill>
-          <a:ln w="19050">
-            <a:solidFill>
-              <a:srgbClr val="000000"/>
-            </a:solidFill>
-            <a:prstDash val="solid"/>
-          </a:ln>
-        </p:spPr>
-      </p:sp>
-      <p:sp>
-        <p:nvSpPr>
-          <p:cNvPr id="16" name="Text 13"/>
-          <p:cNvSpPr txBox="1"/>
-          <p:nvPr/>
-        </p:nvSpPr>
-        <p:spPr>
-          <a:xfrm>
-            <a:off x="5257800" y="1783080"/>
-            <a:ext cx="548640" cy="457200"/>
-          </a:xfrm>
-          <a:prstGeom prst="rect">
-            <a:avLst/>
-          </a:prstGeom>
-          <a:noFill/>
-          <a:ln/>
-        </p:spPr>
-        <p:txBody>
-          <a:bodyPr wrap="square" lIns="0" tIns="0" rIns="0" bIns="0" rtlCol="0" anchor="ctr"/>
-          <a:lstStyle/>
-          <a:p>
-            <a:pPr indent="0" marL="0">
-              <a:buNone/>
-            </a:pPr>
-            <a:r>
-              <a:rPr lang="en-US" sz="2800" b="1" dirty="0">
-                <a:solidFill>
-                  <a:srgbClr val="FFFFFF"/>
-                </a:solidFill>
-                <a:latin typeface="Arial" pitchFamily="34" charset="0"/>
-                <a:ea typeface="Arial" pitchFamily="34" charset="-122"/>
-                <a:cs typeface="Arial" pitchFamily="34" charset="-120"/>
-              </a:rPr>
-              <a:t>2</a:t>
-            </a:r>
-            <a:endParaRPr lang="en-US" sz="2800" dirty="0"/>
-          </a:p>
-        </p:txBody>
-      </p:sp>
-      <p:sp>
-        <p:nvSpPr>
-          <p:cNvPr id="17" name="Text 14"/>
-          <p:cNvSpPr txBox="1"/>
-          <p:nvPr/>
-        </p:nvSpPr>
-        <p:spPr>
-          <a:xfrm>
-            <a:off x="5715000" y="1783080"/>
-            <a:ext cx="1005840" cy="457200"/>
-          </a:xfrm>
-          <a:prstGeom prst="rect">
-            <a:avLst/>
-          </a:prstGeom>
-          <a:noFill/>
-          <a:ln/>
-        </p:spPr>
-        <p:txBody>
-          <a:bodyPr wrap="square" lIns="0" tIns="0" rIns="0" bIns="0" rtlCol="0" anchor="ctr"/>
-          <a:lstStyle/>
-          <a:p>
-            <a:pPr indent="0" marL="0">
-              <a:buNone/>
-            </a:pPr>
-            <a:r>
-              <a:rPr lang="en-US" sz="1400" b="1" dirty="0">
-                <a:solidFill>
-                  <a:srgbClr val="FFFFFF"/>
-                </a:solidFill>
-                <a:latin typeface="Arial" pitchFamily="34" charset="0"/>
-                <a:ea typeface="Arial" pitchFamily="34" charset="-122"/>
-                <a:cs typeface="Arial" pitchFamily="34" charset="-120"/>
-              </a:rPr>
-              <a:t>Start</a:t>
-            </a:r>
-            <a:endParaRPr lang="en-US" sz="1400" dirty="0"/>
-          </a:p>
-        </p:txBody>
-      </p:sp>
-      <p:sp>
-        <p:nvSpPr>
-          <p:cNvPr id="18" name="Text 15"/>
-          <p:cNvSpPr txBox="1"/>
-          <p:nvPr/>
-        </p:nvSpPr>
-        <p:spPr>
-          <a:xfrm>
-            <a:off x="5257800" y="2331720"/>
-            <a:ext cx="1463040" cy="777240"/>
-          </a:xfrm>
-          <a:prstGeom prst="rect">
-            <a:avLst/>
-          </a:prstGeom>
-          <a:noFill/>
-          <a:ln/>
-        </p:spPr>
-        <p:txBody>
-          <a:bodyPr wrap="square" lIns="0" tIns="0" rIns="0" bIns="0" rtlCol="0" anchor="t"/>
-          <a:lstStyle/>
-          <a:p>
-            <a:pPr indent="0" marL="0">
-              <a:buNone/>
-            </a:pPr>
-            <a:r>
-              <a:rPr lang="en-US" sz="1100" dirty="0">
-                <a:solidFill>
-                  <a:srgbClr val="BFBFBF"/>
-                </a:solidFill>
-                <a:latin typeface="Courier New" pitchFamily="34" charset="0"/>
-                <a:ea typeface="Courier New" pitchFamily="34" charset="-122"/>
-                <a:cs typeface="Courier New" pitchFamily="34" charset="-120"/>
-              </a:rPr>
-              <a:t>python -m app.cli serve --port 11435</a:t>
-            </a:r>
-            <a:endParaRPr lang="en-US" sz="1100" dirty="0"/>
-          </a:p>
-        </p:txBody>
-      </p:sp>
-      <p:sp>
-        <p:nvSpPr>
-          <p:cNvPr id="19" name="Shape 16"/>
-          <p:cNvSpPr/>
-          <p:nvPr/>
-        </p:nvSpPr>
-        <p:spPr>
-          <a:xfrm>
-            <a:off x="6995160" y="1691640"/>
-            <a:ext cx="1691640" cy="1508760"/>
-          </a:xfrm>
-          <a:prstGeom prst="rect">
-            <a:avLst/>
-          </a:prstGeom>
-          <a:solidFill>
-            <a:srgbClr val="FFFFFF"/>
-          </a:solidFill>
-          <a:ln w="19050">
-            <a:solidFill>
-              <a:srgbClr val="000000"/>
-            </a:solidFill>
-            <a:prstDash val="solid"/>
-          </a:ln>
-        </p:spPr>
-      </p:sp>
-      <p:sp>
-        <p:nvSpPr>
-          <p:cNvPr id="20" name="Text 17"/>
-          <p:cNvSpPr txBox="1"/>
-          <p:nvPr/>
-        </p:nvSpPr>
-        <p:spPr>
-          <a:xfrm>
-            <a:off x="7132320" y="1783080"/>
-            <a:ext cx="548640" cy="457200"/>
-          </a:xfrm>
-          <a:prstGeom prst="rect">
-            <a:avLst/>
-          </a:prstGeom>
-          <a:noFill/>
-          <a:ln/>
-        </p:spPr>
-        <p:txBody>
-          <a:bodyPr wrap="square" lIns="0" tIns="0" rIns="0" bIns="0" rtlCol="0" anchor="ctr"/>
-          <a:lstStyle/>
-          <a:p>
-            <a:pPr indent="0" marL="0">
-              <a:buNone/>
-            </a:pPr>
-            <a:r>
-              <a:rPr lang="en-US" sz="2800" b="1" dirty="0">
-                <a:solidFill>
-                  <a:srgbClr val="000000"/>
-                </a:solidFill>
-                <a:latin typeface="Arial" pitchFamily="34" charset="0"/>
-                <a:ea typeface="Arial" pitchFamily="34" charset="-122"/>
-                <a:cs typeface="Arial" pitchFamily="34" charset="-120"/>
-              </a:rPr>
-              <a:t>3</a:t>
-            </a:r>
-            <a:endParaRPr lang="en-US" sz="2800" dirty="0"/>
-          </a:p>
-        </p:txBody>
-      </p:sp>
-      <p:sp>
-        <p:nvSpPr>
-          <p:cNvPr id="21" name="Text 18"/>
-          <p:cNvSpPr txBox="1"/>
-          <p:nvPr/>
-        </p:nvSpPr>
-        <p:spPr>
-          <a:xfrm>
-            <a:off x="7589520" y="1783080"/>
-            <a:ext cx="1005840" cy="457200"/>
-          </a:xfrm>
-          <a:prstGeom prst="rect">
-            <a:avLst/>
-          </a:prstGeom>
-          <a:noFill/>
-          <a:ln/>
-        </p:spPr>
-        <p:txBody>
-          <a:bodyPr wrap="square" lIns="0" tIns="0" rIns="0" bIns="0" rtlCol="0" anchor="ctr"/>
-          <a:lstStyle/>
-          <a:p>
-            <a:pPr indent="0" marL="0">
-              <a:buNone/>
-            </a:pPr>
-            <a:r>
-              <a:rPr lang="en-US" sz="1400" b="1" dirty="0">
-                <a:solidFill>
-                  <a:srgbClr val="000000"/>
-                </a:solidFill>
-                <a:latin typeface="Arial" pitchFamily="34" charset="0"/>
-                <a:ea typeface="Arial" pitchFamily="34" charset="-122"/>
-                <a:cs typeface="Arial" pitchFamily="34" charset="-120"/>
-              </a:rPr>
-              <a:t>Repoint</a:t>
-            </a:r>
-            <a:endParaRPr lang="en-US" sz="1400" dirty="0"/>
-          </a:p>
-        </p:txBody>
-      </p:sp>
-      <p:sp>
-        <p:nvSpPr>
-          <p:cNvPr id="22" name="Text 19"/>
-          <p:cNvSpPr txBox="1"/>
-          <p:nvPr/>
-        </p:nvSpPr>
-        <p:spPr>
-          <a:xfrm>
-            <a:off x="7132320" y="2331720"/>
-            <a:ext cx="1463040" cy="777240"/>
-          </a:xfrm>
-          <a:prstGeom prst="rect">
-            <a:avLst/>
-          </a:prstGeom>
-          <a:noFill/>
-          <a:ln/>
-        </p:spPr>
-        <p:txBody>
-          <a:bodyPr wrap="square" lIns="0" tIns="0" rIns="0" bIns="0" rtlCol="0" anchor="t"/>
-          <a:lstStyle/>
-          <a:p>
-            <a:pPr indent="0" marL="0">
-              <a:buNone/>
-            </a:pPr>
-            <a:r>
-              <a:rPr lang="en-US" sz="1100" dirty="0">
-                <a:solidFill>
-                  <a:srgbClr val="262626"/>
-                </a:solidFill>
-                <a:latin typeface="Courier New" pitchFamily="34" charset="0"/>
-                <a:ea typeface="Courier New" pitchFamily="34" charset="-122"/>
-                <a:cs typeface="Courier New" pitchFamily="34" charset="-120"/>
-              </a:rPr>
-              <a:t>Agent base URL: http://127.0.0.1:11435</a:t>
-            </a:r>
-            <a:endParaRPr lang="en-US" sz="1100" dirty="0"/>
-          </a:p>
-        </p:txBody>
-      </p:sp>
-      <p:sp>
-        <p:nvSpPr>
-          <p:cNvPr id="23" name="Shape 20"/>
-          <p:cNvSpPr/>
-          <p:nvPr/>
-        </p:nvSpPr>
-        <p:spPr>
-          <a:xfrm>
-            <a:off x="3246120" y="3383280"/>
-            <a:ext cx="5440680" cy="1143000"/>
-          </a:xfrm>
-          <a:prstGeom prst="rect">
-            <a:avLst/>
-          </a:prstGeom>
-          <a:solidFill>
-            <a:srgbClr val="000000"/>
-          </a:solidFill>
-          <a:ln w="19050">
-            <a:solidFill>
-              <a:srgbClr val="000000"/>
-            </a:solidFill>
-            <a:prstDash val="solid"/>
-          </a:ln>
-        </p:spPr>
-      </p:sp>
-      <p:sp>
-        <p:nvSpPr>
-          <p:cNvPr id="24" name="Text 21"/>
-          <p:cNvSpPr txBox="1"/>
-          <p:nvPr/>
-        </p:nvSpPr>
-        <p:spPr>
-          <a:xfrm>
-            <a:off x="3474720" y="3383280"/>
-            <a:ext cx="4983480" cy="1143000"/>
-          </a:xfrm>
-          <a:prstGeom prst="rect">
-            <a:avLst/>
-          </a:prstGeom>
-          <a:noFill/>
-          <a:ln/>
-        </p:spPr>
-        <p:txBody>
-          <a:bodyPr wrap="square" lIns="0" tIns="0" rIns="0" bIns="0" rtlCol="0" anchor="ctr"/>
-          <a:lstStyle/>
-          <a:p>
-            <a:pPr indent="0" marL="0">
-              <a:buNone/>
-            </a:pPr>
-            <a:r>
-              <a:rPr lang="en-US" sz="1300" b="1" dirty="0">
-                <a:solidFill>
-                  <a:srgbClr val="FFFFFF"/>
-                </a:solidFill>
-                <a:latin typeface="Arial" pitchFamily="34" charset="0"/>
-                <a:ea typeface="Arial" pitchFamily="34" charset="-122"/>
-                <a:cs typeface="Arial" pitchFamily="34" charset="-120"/>
-              </a:rPr>
-              <a:t>Honest status: </a:t>
-            </a:r>
-            <a:pPr indent="0" marL="0">
-              <a:buNone/>
-            </a:pPr>
-            <a:r>
-              <a:rPr lang="en-US" sz="1300" dirty="0">
-                <a:solidFill>
-                  <a:srgbClr val="FFFFFF"/>
-                </a:solidFill>
-                <a:latin typeface="Arial" pitchFamily="34" charset="0"/>
-                <a:ea typeface="Arial" pitchFamily="34" charset="-122"/>
-                <a:cs typeface="Arial" pitchFamily="34" charset="-120"/>
-              </a:rPr>
-              <a:t>built and validated, not yet in front of real users. Next: interview real local AI users and ask for unvarnished feedback, then loop back to Empathize.</a:t>
-            </a:r>
-            <a:endParaRPr lang="en-US" sz="1300" dirty="0"/>
+              <a:t>Not yet in front of real users.</a:t>
+            </a:r>
+            <a:endParaRPr lang="en-US" sz="1200" dirty="0"/>
           </a:p>
         </p:txBody>
       </p:sp>

</xml_diff>